<commit_message>
Re-render E files after stability table fix
</commit_message>
<xml_diff>
--- a/output/archive/WestravelleData/Stability/CVL/WA-2020-313/Readouts/Client/CVL_StabilityReview_QA-APPROVED.pptx
+++ b/output/archive/WestravelleData/Stability/CVL/WA-2020-313/Readouts/Client/CVL_StabilityReview_QA-APPROVED.pptx
@@ -4845,7 +4845,7 @@
                         <a:rPr sz="1000">
                           <a:latin typeface="Arial"/>
                         </a:rPr>
-                        <a:t>99.8</a:t>
+                        <a:t>100.6</a:t>
                       </a:r>
                     </a:p>
                   </a:txBody>
@@ -5307,22 +5307,22 @@
                         <a:rPr sz="1000">
                           <a:latin typeface="Arial"/>
                         </a:rPr>
-                        <a:t>100.3</a:t>
-                      </a:r>
-                    </a:p>
-                  </a:txBody>
-                  <a:tcPr/>
-                </a:tc>
-                <a:tc>
-                  <a:txBody>
-                    <a:bodyPr/>
-                    <a:lstStyle/>
-                    <a:p>
-                      <a:r>
-                        <a:rPr sz="1000">
-                          <a:latin typeface="Arial"/>
-                        </a:rPr>
-                        <a:t>0.25</a:t>
+                        <a:t>100.6</a:t>
+                      </a:r>
+                    </a:p>
+                  </a:txBody>
+                  <a:tcPr/>
+                </a:tc>
+                <a:tc>
+                  <a:txBody>
+                    <a:bodyPr/>
+                    <a:lstStyle/>
+                    <a:p>
+                      <a:r>
+                        <a:rPr sz="1000">
+                          <a:latin typeface="Arial"/>
+                        </a:rPr>
+                        <a:t>0.19</a:t>
                       </a:r>
                     </a:p>
                   </a:txBody>

</xml_diff>